<commit_message>
After Track A: the owner's follow-ups of 22 October (the seed clock, the public landing page and its QR code, the friendlier workspace, the team repository, the text pass) and the depth plan for Track C with its four research notes and the Codex review
</commit_message>
<xml_diff>
--- a/docs/presentation/sample-CS310-meeting-brief.pptx
+++ b/docs/presentation/sample-CS310-meeting-brief.pptx
@@ -2657,7 +2657,7 @@
                 <a:ea typeface="Calibri" pitchFamily="34" charset="-122"/>
                 <a:cs typeface="Calibri" pitchFamily="34" charset="-120"/>
               </a:rPr>
-              <a:t>Prepared by Dr Sobri on 2026-07-01T10:00:00Z.</a:t>
+              <a:t>Prepared by Dr Sobri on 2026-10-22T10:00:00Z.</a:t>
             </a:r>
             <a:endParaRPr lang="en-US" sz="1400" dirty="0"/>
           </a:p>
@@ -2831,7 +2831,7 @@
                 <a:ea typeface="Calibri" pitchFamily="34" charset="-122"/>
                 <a:cs typeface="Calibri" pitchFamily="34" charset="-120"/>
               </a:rPr>
-              <a:t>Stripe. Published 2026-09-25. Recorded 2026-07-01T10:00:00Z from Saved sample: real postings from the stripe Greenhouse board, retrieved 2026-10-09 and truncated for the demo.</a:t>
+              <a:t>Stripe. Published 2026-09-25. Recorded 2026-10-22T10:00:00Z from Saved sample: real postings from the stripe Greenhouse board, retrieved 2026-10-09 and truncated for the demo.</a:t>
             </a:r>
             <a:endParaRPr lang="en-US" sz="1400" dirty="0"/>
           </a:p>
@@ -3072,7 +3072,7 @@
                 <a:ea typeface="Calibri" pitchFamily="34" charset="-122"/>
                 <a:cs typeface="Calibri" pitchFamily="34" charset="-120"/>
               </a:rPr>
-              <a:t>Stripe. Published 2026-10-01. Recorded 2026-07-01T10:00:00Z from Saved sample: real postings from the stripe Greenhouse board, retrieved 2026-10-09 and truncated for the demo.</a:t>
+              <a:t>Stripe. Published 2026-10-01. Recorded 2026-10-22T10:00:00Z from Saved sample: real postings from the stripe Greenhouse board, retrieved 2026-10-09 and truncated for the demo.</a:t>
             </a:r>
             <a:endParaRPr lang="en-US" sz="1400" dirty="0"/>
           </a:p>
@@ -3271,7 +3271,7 @@
                 <a:ea typeface="Calibri" pitchFamily="34" charset="-122"/>
                 <a:cs typeface="Calibri" pitchFamily="34" charset="-120"/>
               </a:rPr>
-              <a:t>Stripe. Published 2026-09-10. Recorded 2026-07-01T10:00:00Z from Saved sample: real postings from the stripe Greenhouse board, retrieved 2026-10-09 and truncated for the demo.</a:t>
+              <a:t>Stripe. Published 2026-09-10. Recorded 2026-10-22T10:00:00Z from Saved sample: real postings from the stripe Greenhouse board, retrieved 2026-10-09 and truncated for the demo.</a:t>
             </a:r>
             <a:endParaRPr lang="en-US" sz="1400" dirty="0"/>
           </a:p>
@@ -3533,7 +3533,7 @@
                 <a:ea typeface="Calibri" pitchFamily="34" charset="-122"/>
                 <a:cs typeface="Calibri" pitchFamily="34" charset="-120"/>
               </a:rPr>
-              <a:t>Stripe. Published 2026-07-13. Recorded 2026-07-01T10:00:00Z from Saved sample: real postings from the stripe Greenhouse board, retrieved 2026-10-09 and truncated for the demo.</a:t>
+              <a:t>Stripe. Published 2026-07-13. Recorded 2026-10-22T10:00:00Z from Saved sample: real postings from the stripe Greenhouse board, retrieved 2026-10-09 and truncated for the demo.</a:t>
             </a:r>
             <a:endParaRPr lang="en-US" sz="1400" dirty="0"/>
           </a:p>
@@ -3732,7 +3732,7 @@
                 <a:ea typeface="Calibri" pitchFamily="34" charset="-122"/>
                 <a:cs typeface="Calibri" pitchFamily="34" charset="-120"/>
               </a:rPr>
-              <a:t>Stripe. Published 2026-04-22. Recorded 2026-07-01T10:00:00Z from Saved sample: real postings from the stripe Greenhouse board, retrieved 2026-10-09 and truncated for the demo.</a:t>
+              <a:t>Stripe. Published 2026-04-22. Recorded 2026-10-22T10:00:00Z from Saved sample: real postings from the stripe Greenhouse board, retrieved 2026-10-09 and truncated for the demo.</a:t>
             </a:r>
             <a:endParaRPr lang="en-US" sz="1400" dirty="0"/>
           </a:p>
@@ -3973,7 +3973,7 @@
                 <a:ea typeface="Calibri" pitchFamily="34" charset="-122"/>
                 <a:cs typeface="Calibri" pitchFamily="34" charset="-120"/>
               </a:rPr>
-              <a:t>Stripe. Published 2026-05-14. Recorded 2026-07-01T10:00:00Z from Saved sample: real postings from the stripe Greenhouse board, retrieved 2026-10-09 and truncated for the demo.</a:t>
+              <a:t>Stripe. Published 2026-05-14. Recorded 2026-10-22T10:00:00Z from Saved sample: real postings from the stripe Greenhouse board, retrieved 2026-10-09 and truncated for the demo.</a:t>
             </a:r>
             <a:endParaRPr lang="en-US" sz="1400" dirty="0"/>
           </a:p>
@@ -4172,7 +4172,7 @@
                 <a:ea typeface="Calibri" pitchFamily="34" charset="-122"/>
                 <a:cs typeface="Calibri" pitchFamily="34" charset="-120"/>
               </a:rPr>
-              <a:t>Stripe. Published 2026-09-22. Recorded 2026-07-01T10:00:00Z from Saved sample: real postings from the stripe Greenhouse board, retrieved 2026-10-09 and truncated for the demo.</a:t>
+              <a:t>Stripe. Published 2026-09-22. Recorded 2026-10-22T10:00:00Z from Saved sample: real postings from the stripe Greenhouse board, retrieved 2026-10-09 and truncated for the demo.</a:t>
             </a:r>
             <a:endParaRPr lang="en-US" sz="1400" dirty="0"/>
           </a:p>
@@ -4413,7 +4413,7 @@
                 <a:ea typeface="Calibri" pitchFamily="34" charset="-122"/>
                 <a:cs typeface="Calibri" pitchFamily="34" charset="-120"/>
               </a:rPr>
-              <a:t>Stripe. Published 2024-04-30. Recorded 2026-07-01T10:00:00Z from Saved sample: real postings from the stripe Greenhouse board, retrieved 2026-10-09 and truncated for the demo.</a:t>
+              <a:t>Stripe. Published 2024-04-30. Recorded 2026-10-22T10:00:00Z from Saved sample: real postings from the stripe Greenhouse board, retrieved 2026-10-09 and truncated for the demo.</a:t>
             </a:r>
             <a:endParaRPr lang="en-US" sz="1400" dirty="0"/>
           </a:p>
@@ -8744,7 +8744,7 @@
                 <a:ea typeface="Calibri" pitchFamily="34" charset="-122"/>
                 <a:cs typeface="Calibri" pitchFamily="34" charset="-120"/>
               </a:rPr>
-              <a:t>Stripe. Published 2023-11-01. Recorded 2026-07-01T10:00:00Z from Saved sample: real postings from the stripe Greenhouse board, retrieved 2026-10-09 and truncated for the demo.</a:t>
+              <a:t>Stripe. Published 2023-11-01. Recorded 2026-10-22T10:00:00Z from Saved sample: real postings from the stripe Greenhouse board, retrieved 2026-10-09 and truncated for the demo.</a:t>
             </a:r>
             <a:endParaRPr lang="en-US" sz="1400" dirty="0"/>
           </a:p>

</xml_diff>